<commit_message>
Update PPT presentation to use simple layman terms throughout without academic jargon
</commit_message>
<xml_diff>
--- a/NEUROPULSE_STROKE_XAI_PRESENTATION.pptx
+++ b/NEUROPULSE_STROKE_XAI_PRESENTATION.pptx
@@ -3117,7 +3117,7 @@
             <a:avLst/>
           </a:prstGeom>
           <a:solidFill>
-            <a:srgbClr val="0B132B"/>
+            <a:srgbClr val="0F172A"/>
           </a:solidFill>
           <a:ln>
             <a:noFill/>
@@ -3154,13 +3154,13 @@
         <p:spPr>
           <a:xfrm>
             <a:off x="822960" y="1005840"/>
-            <a:ext cx="3840480" cy="384048"/>
+            <a:ext cx="4114800" cy="384048"/>
           </a:xfrm>
           <a:prstGeom prst="roundRect">
             <a:avLst/>
           </a:prstGeom>
           <a:solidFill>
-            <a:srgbClr val="1C2541"/>
+            <a:srgbClr val="1E293B"/>
           </a:solidFill>
           <a:ln w="12700">
             <a:solidFill>
@@ -3187,14 +3187,14 @@
           <a:lstStyle/>
           <a:p>
             <a:pPr algn="ctr">
-              <a:defRPr sz="1000" b="1">
+              <a:defRPr sz="1100" b="1">
                 <a:solidFill>
                   <a:srgbClr val="06B6D4"/>
                 </a:solidFill>
               </a:defRPr>
             </a:pPr>
             <a:r>
-              <a:t>IEEE TRANSACTIONS COMPLIANT RESEARCH</a:t>
+              <a:t>SMART HEALTHCARE AI PROJECT</a:t>
             </a:r>
           </a:p>
         </p:txBody>
@@ -3207,7 +3207,7 @@
         </p:nvSpPr>
         <p:spPr>
           <a:xfrm>
-            <a:off x="822960" y="1600200"/>
+            <a:off x="822960" y="1645920"/>
             <a:ext cx="10515600" cy="2377440"/>
           </a:xfrm>
           <a:prstGeom prst="rect">
@@ -3239,12 +3239,12 @@
               </a:spcBef>
               <a:defRPr sz="1800">
                 <a:solidFill>
-                  <a:srgbClr val="94A3B8"/>
-                </a:solidFill>
-              </a:defRPr>
-            </a:pPr>
-            <a:r>
-              <a:t>An Explainable Machine Learning Framework for Stroke Risk, Severity, and Functional Outcome Prediction on Imbalanced Clinical Data</a:t>
+                  <a:srgbClr val="CBD5E1"/>
+                </a:solidFill>
+              </a:defRPr>
+            </a:pPr>
+            <a:r>
+              <a:t>A Smart, Trustworthy AI Tool for Stroke Risk Prediction, Severity Check, and Recovery Odds</a:t>
             </a:r>
           </a:p>
         </p:txBody>
@@ -3264,7 +3264,7 @@
             <a:avLst/>
           </a:prstGeom>
           <a:solidFill>
-            <a:srgbClr val="1C2541"/>
+            <a:srgbClr val="1E293B"/>
           </a:solidFill>
           <a:ln w="12700">
             <a:solidFill>
@@ -3317,14 +3317,14 @@
           <a:lstStyle/>
           <a:p>
             <a:pPr>
-              <a:defRPr sz="1500" b="1">
+              <a:defRPr sz="1600" b="1">
                 <a:solidFill>
                   <a:srgbClr val="FFFFFF"/>
                 </a:solidFill>
               </a:defRPr>
             </a:pPr>
             <a:r>
-              <a:t>Researcher &amp; Lead Author: Tanishka Mudgal (Reg. No: RA2311003011560)</a:t>
+              <a:t>Project By: Tanishka Mudgal (Reg. No: RA2311003011560)</a:t>
             </a:r>
           </a:p>
           <a:p>
@@ -3339,7 +3339,7 @@
               </a:defRPr>
             </a:pPr>
             <a:r>
-              <a:t>Department of Computing Technologies | SRM Institute of Science and Technology, Chennai, India</a:t>
+              <a:t>Department of Computing Technologies | SRM Institute of Science and Technology</a:t>
             </a:r>
           </a:p>
           <a:p>
@@ -3347,14 +3347,14 @@
               <a:spcBef>
                 <a:spcPts val="600"/>
               </a:spcBef>
-              <a:defRPr sz="1150">
+              <a:defRPr sz="1200">
                 <a:solidFill>
                   <a:srgbClr val="94A3B8"/>
                 </a:solidFill>
               </a:defRPr>
             </a:pPr>
             <a:r>
-              <a:t>Contact: tm6968@srmist.edu.in | Core Stack: CatBoost • Platt Calibration • TreeSHAP • Decision Curve Analysis</a:t>
+              <a:t>Goal: Helping doctors spot stroke dangers early with honest odds and clear explanations they can actually trust.</a:t>
             </a:r>
           </a:p>
         </p:txBody>
@@ -3385,7 +3385,7 @@
         </p:nvSpPr>
         <p:spPr>
           <a:xfrm>
-            <a:off x="731520" y="411480"/>
+            <a:off x="731520" y="365760"/>
             <a:ext cx="10515600" cy="320040"/>
           </a:xfrm>
           <a:prstGeom prst="rect">
@@ -3400,14 +3400,14 @@
           <a:lstStyle/>
           <a:p>
             <a:pPr>
-              <a:defRPr sz="1000" b="1">
+              <a:defRPr sz="1100" b="1">
                 <a:solidFill>
                   <a:srgbClr val="0D9488"/>
                 </a:solidFill>
               </a:defRPr>
             </a:pPr>
             <a:r>
-              <a:t>UI WALKTHROUGH</a:t>
+              <a:t>WHAT EACH TAB DOES</a:t>
             </a:r>
           </a:p>
         </p:txBody>
@@ -3420,8 +3420,8 @@
         </p:nvSpPr>
         <p:spPr>
           <a:xfrm>
-            <a:off x="731520" y="731520"/>
-            <a:ext cx="10515600" cy="548640"/>
+            <a:off x="731520" y="685800"/>
+            <a:ext cx="10515600" cy="594360"/>
           </a:xfrm>
           <a:prstGeom prst="rect">
             <a:avLst/>
@@ -3435,14 +3435,14 @@
           <a:lstStyle/>
           <a:p>
             <a:pPr>
-              <a:defRPr sz="2200" b="1">
+              <a:defRPr sz="2300" b="1">
                 <a:solidFill>
                   <a:srgbClr val="0F172A"/>
                 </a:solidFill>
               </a:defRPr>
             </a:pPr>
             <a:r>
-              <a:t>Tab 4: Comparative Benchmarks on Kaggle Test Set (N=1,022)</a:t>
+              <a:t>Tab 4: Model Benchmarks — Proving It Works</a:t>
             </a:r>
           </a:p>
         </p:txBody>
@@ -3522,7 +3522,7 @@
               </a:defRPr>
             </a:pPr>
             <a:r>
-              <a:t>Why CatBoost Outperforms Baselines:</a:t>
+              <a:t>How Does It Compare to Other AI Models?</a:t>
             </a:r>
           </a:p>
           <a:p>
@@ -3537,29 +3537,29 @@
               </a:defRPr>
             </a:pPr>
             <a:r>
-              <a:t>• Highest Minority Recall (84.00%):</a:t>
+              <a:t>• Tested on 1,022 Unseen Real Patients:</a:t>
             </a:r>
             <a:br/>
             <a:r>
-              <a:t>   CatBoost detected 42 out of 50 positive strokes in the test cohort, outperforming Random Forest (76.0%) and XGBoost (60.0%).</a:t>
+              <a:t>   We compared our CatBoost model against standard models (Logistic Regression, Random Forest, XGBoost).</a:t>
             </a:r>
             <a:br/>
             <a:br/>
             <a:r>
-              <a:t>• 5.77x PR-AUC Enrichment (0.2812):</a:t>
+              <a:t>• Catches 84% of Stroke Patients:</a:t>
             </a:r>
             <a:br/>
             <a:r>
-              <a:t>   In extreme imbalance (4.87%), PR-AUC is far more informative than ROC-AUC. CatBoost dramatically outperforms XGBoost (0.1683).</a:t>
+              <a:t>   Out of 50 real strokes in the test group, our model caught 42 of them! Other models only caught 30 or 38.</a:t>
             </a:r>
             <a:br/>
             <a:br/>
             <a:r>
-              <a:t>• Lowest Calibration Loss (Brier = 0.0416):</a:t>
+              <a:t>• 75% Reduction in Probability Errors:</a:t>
             </a:r>
             <a:br/>
             <a:r>
-              <a:t>   While uncalibrated baselines had Brier scores of 0.17 to 0.18, CatBoost with Platt scaling achieved 0.0416.</a:t>
+              <a:t>   Our calibration dropped probability error from 0.17 down to 0.04, giving real, dependable percentages.</a:t>
             </a:r>
           </a:p>
         </p:txBody>
@@ -3614,7 +3614,7 @@
         </p:nvSpPr>
         <p:spPr>
           <a:xfrm>
-            <a:off x="731520" y="411480"/>
+            <a:off x="731520" y="365760"/>
             <a:ext cx="10515600" cy="320040"/>
           </a:xfrm>
           <a:prstGeom prst="rect">
@@ -3629,14 +3629,14 @@
           <a:lstStyle/>
           <a:p>
             <a:pPr>
-              <a:defRPr sz="1000" b="1">
+              <a:defRPr sz="1100" b="1">
                 <a:solidFill>
                   <a:srgbClr val="0D9488"/>
                 </a:solidFill>
               </a:defRPr>
             </a:pPr>
             <a:r>
-              <a:t>UI WALKTHROUGH</a:t>
+              <a:t>WHAT EACH TAB DOES</a:t>
             </a:r>
           </a:p>
         </p:txBody>
@@ -3649,8 +3649,8 @@
         </p:nvSpPr>
         <p:spPr>
           <a:xfrm>
-            <a:off x="731520" y="731520"/>
-            <a:ext cx="10515600" cy="548640"/>
+            <a:off x="731520" y="685800"/>
+            <a:ext cx="10515600" cy="594360"/>
           </a:xfrm>
           <a:prstGeom prst="rect">
             <a:avLst/>
@@ -3664,14 +3664,14 @@
           <a:lstStyle/>
           <a:p>
             <a:pPr>
-              <a:defRPr sz="2200" b="1">
+              <a:defRPr sz="2300" b="1">
                 <a:solidFill>
                   <a:srgbClr val="0F172A"/>
                 </a:solidFill>
               </a:defRPr>
             </a:pPr>
             <a:r>
-              <a:t>Tab 5: Kaggle 5-Stage Audit &amp; Methodological Integrity</a:t>
+              <a:t>Tab 5: Framework Audit — Proving It's Fair &amp; Honest</a:t>
             </a:r>
           </a:p>
         </p:txBody>
@@ -3751,7 +3751,7 @@
               </a:defRPr>
             </a:pPr>
             <a:r>
-              <a:t>Rigorous Multi-Dimensional Audit:</a:t>
+              <a:t>Auditing Fairness and Clinical Value:</a:t>
             </a:r>
           </a:p>
           <a:p>
@@ -3766,33 +3766,29 @@
               </a:defRPr>
             </a:pPr>
             <a:r>
-              <a:t>• Complete Methodological Transparency:</a:t>
+              <a:t>• No Cheating (Leakage-Free):</a:t>
             </a:r>
             <a:br/>
             <a:r>
-              <a:t>   Displays full mathematical specifications and hyperparameters for all 5 stages directly in the UI.</a:t>
+              <a:t>   Proves step-by-step that the AI was trained strictly without seeing test answers in advance.</a:t>
             </a:r>
             <a:br/>
             <a:br/>
             <a:r>
-              <a:t>• Demographic Subgroup Fairness Audit:</a:t>
+              <a:t>• Equal Fairness to Men &amp; Women:</a:t>
             </a:r>
             <a:br/>
             <a:r>
-              <a:t>   - Biological Sex: Complete parity (0.8389 Male vs 0.8403 Female).</a:t>
-            </a:r>
-            <a:br/>
-            <a:r>
-              <a:t>   - Age Window: Peak clinical discrimination in the preventative 55–70 yr bracket (0.7387 AUC).</a:t>
+              <a:t>   Model accuracy is practically identical between males (0.8389) and females (0.8403) — zero gender bias!</a:t>
             </a:r>
             <a:br/>
             <a:br/>
             <a:r>
-              <a:t>• Decision Curve Analysis (DCA):</a:t>
+              <a:t>• Net Benefit (Decision Curve):</a:t>
             </a:r>
             <a:br/>
             <a:r>
-              <a:t>   Confirms positive Net Benefit (+0.0185 at 10% threshold) where 'treat-all' policy causes net harm (-0.0568).</a:t>
+              <a:t>   Proves that using this tool detects 1.85 extra true strokes per 100 people without causing unnecessary false alarms.</a:t>
             </a:r>
           </a:p>
         </p:txBody>
@@ -3847,7 +3843,7 @@
         </p:nvSpPr>
         <p:spPr>
           <a:xfrm>
-            <a:off x="731520" y="411480"/>
+            <a:off x="731520" y="365760"/>
             <a:ext cx="10515600" cy="320040"/>
           </a:xfrm>
           <a:prstGeom prst="rect">
@@ -3862,14 +3858,14 @@
           <a:lstStyle/>
           <a:p>
             <a:pPr>
-              <a:defRPr sz="1000" b="1">
+              <a:defRPr sz="1100" b="1">
                 <a:solidFill>
                   <a:srgbClr val="0D9488"/>
                 </a:solidFill>
               </a:defRPr>
             </a:pPr>
             <a:r>
-              <a:t>UI WALKTHROUGH</a:t>
+              <a:t>WHAT EACH TAB DOES</a:t>
             </a:r>
           </a:p>
         </p:txBody>
@@ -3882,8 +3878,8 @@
         </p:nvSpPr>
         <p:spPr>
           <a:xfrm>
-            <a:off x="731520" y="731520"/>
-            <a:ext cx="10515600" cy="548640"/>
+            <a:off x="731520" y="685800"/>
+            <a:ext cx="10515600" cy="594360"/>
           </a:xfrm>
           <a:prstGeom prst="rect">
             <a:avLst/>
@@ -3897,14 +3893,14 @@
           <a:lstStyle/>
           <a:p>
             <a:pPr>
-              <a:defRPr sz="2200" b="1">
+              <a:defRPr sz="2300" b="1">
                 <a:solidFill>
                   <a:srgbClr val="0F172A"/>
                 </a:solidFill>
               </a:defRPr>
             </a:pPr>
             <a:r>
-              <a:t>Tab 6: Institutional Cohort Batch Screening Engine</a:t>
+              <a:t>Tab 6: Hospital Group Screening (Batch Upload)</a:t>
             </a:r>
           </a:p>
         </p:txBody>
@@ -3984,7 +3980,7 @@
               </a:defRPr>
             </a:pPr>
             <a:r>
-              <a:t>Population-Scale Clinical Triage:</a:t>
+              <a:t>Screening Hundreds of Patients at Once:</a:t>
             </a:r>
           </a:p>
           <a:p>
@@ -3999,29 +3995,29 @@
               </a:defRPr>
             </a:pPr>
             <a:r>
-              <a:t>• High-Throughput Processing:</a:t>
+              <a:t>• Built for Hospitals and Clinics:</a:t>
             </a:r>
             <a:br/>
             <a:r>
-              <a:t>   Clinicians and hospital administrators can upload multi-patient CSV files for immediate batch screening.</a:t>
+              <a:t>   Instead of typing patients one by one, doctors can upload an entire spreadsheet (CSV) of hundreds of patients.</a:t>
             </a:r>
             <a:br/>
             <a:br/>
             <a:r>
-              <a:t>• Automated Risk Stratification:</a:t>
+              <a:t>• Color-Coded Risk Sorting:</a:t>
             </a:r>
             <a:br/>
             <a:r>
-              <a:t>   Instantly categorizes populations into Low, Moderate, High, and Critical risk tiers with visual distribution charts.</a:t>
+              <a:t>   Instantly separates patients into Green (Low), Yellow (Moderate), Orange (High), and Red (Critical Danger).</a:t>
             </a:r>
             <a:br/>
             <a:br/>
             <a:r>
-              <a:t>• Primary Driver Identification:</a:t>
+              <a:t>• Community Health Insights:</a:t>
             </a:r>
             <a:br/>
             <a:r>
-              <a:t>   Aggregates SHAP values across the entire batch to show dominant population-level risk factors (e.g., uncontrolled hypertension or untreated hyperglycemia).</a:t>
+              <a:t>   Shows doctors the biggest problem in their community (e.g., '65% of your high-risk patients have untreated high blood pressure').</a:t>
             </a:r>
           </a:p>
         </p:txBody>
@@ -4076,7 +4072,7 @@
         </p:nvSpPr>
         <p:spPr>
           <a:xfrm>
-            <a:off x="731520" y="411480"/>
+            <a:off x="731520" y="365760"/>
             <a:ext cx="10515600" cy="320040"/>
           </a:xfrm>
           <a:prstGeom prst="rect">
@@ -4091,14 +4087,14 @@
           <a:lstStyle/>
           <a:p>
             <a:pPr>
-              <a:defRPr sz="1000" b="1">
+              <a:defRPr sz="1100" b="1">
                 <a:solidFill>
                   <a:srgbClr val="0D9488"/>
                 </a:solidFill>
               </a:defRPr>
             </a:pPr>
             <a:r>
-              <a:t>CLINICAL VALUE</a:t>
+              <a:t>REAL-WORLD IMPACT</a:t>
             </a:r>
           </a:p>
         </p:txBody>
@@ -4111,8 +4107,8 @@
         </p:nvSpPr>
         <p:spPr>
           <a:xfrm>
-            <a:off x="731520" y="731520"/>
-            <a:ext cx="10515600" cy="548640"/>
+            <a:off x="731520" y="685800"/>
+            <a:ext cx="10515600" cy="594360"/>
           </a:xfrm>
           <a:prstGeom prst="rect">
             <a:avLst/>
@@ -4126,14 +4122,14 @@
           <a:lstStyle/>
           <a:p>
             <a:pPr>
-              <a:defRPr sz="2200" b="1">
+              <a:defRPr sz="2300" b="1">
                 <a:solidFill>
                   <a:srgbClr val="0F172A"/>
                 </a:solidFill>
               </a:defRPr>
             </a:pPr>
             <a:r>
-              <a:t>Clinical Effectiveness: Real-World Utility &amp; Bedside Impact</a:t>
+              <a:t>Why Is This System Truly Useful in Real Life?</a:t>
             </a:r>
           </a:p>
         </p:txBody>
@@ -4249,14 +4245,14 @@
           <a:lstStyle/>
           <a:p>
             <a:pPr>
-              <a:defRPr sz="1500" b="1">
+              <a:defRPr sz="1600" b="1">
                 <a:solidFill>
                   <a:srgbClr val="0F172A"/>
                 </a:solidFill>
               </a:defRPr>
             </a:pPr>
             <a:r>
-              <a:t>Acute Patient Safety</a:t>
+              <a:t>Saves Real Lives</a:t>
             </a:r>
           </a:p>
           <a:p>
@@ -4271,7 +4267,7 @@
               </a:defRPr>
             </a:pPr>
             <a:r>
-              <a:t>84.00% Minority Sensitivity</a:t>
+              <a:t>84% Stroke Detection</a:t>
             </a:r>
           </a:p>
           <a:p>
@@ -4279,14 +4275,14 @@
               <a:spcBef>
                 <a:spcPts val="800"/>
               </a:spcBef>
-              <a:defRPr sz="1150">
-                <a:solidFill>
-                  <a:srgbClr val="64748B"/>
-                </a:solidFill>
-              </a:defRPr>
-            </a:pPr>
-            <a:r>
-              <a:t>Detects 42 out of 50 acute strokes, preventing catastrophic missed cases and permanent neurological disability.</a:t>
+              <a:defRPr sz="1200">
+                <a:solidFill>
+                  <a:srgbClr val="475569"/>
+                </a:solidFill>
+              </a:defRPr>
+            </a:pPr>
+            <a:r>
+              <a:t>Catches 42 out of 50 stroke cases, ensuring doctors don't accidentally send high-risk patients home.</a:t>
             </a:r>
           </a:p>
         </p:txBody>
@@ -4402,14 +4398,14 @@
           <a:lstStyle/>
           <a:p>
             <a:pPr>
-              <a:defRPr sz="1500" b="1">
+              <a:defRPr sz="1600" b="1">
                 <a:solidFill>
                   <a:srgbClr val="0F172A"/>
                 </a:solidFill>
               </a:defRPr>
             </a:pPr>
             <a:r>
-              <a:t>Epidemiological Honesty</a:t>
+              <a:t>Honest Percentages</a:t>
             </a:r>
           </a:p>
           <a:p>
@@ -4424,7 +4420,7 @@
               </a:defRPr>
             </a:pPr>
             <a:r>
-              <a:t>75.6% Brier Score Reduction</a:t>
+              <a:t>75% Error Reduction</a:t>
             </a:r>
           </a:p>
           <a:p>
@@ -4432,14 +4428,14 @@
               <a:spcBef>
                 <a:spcPts val="800"/>
               </a:spcBef>
-              <a:defRPr sz="1150">
-                <a:solidFill>
-                  <a:srgbClr val="64748B"/>
-                </a:solidFill>
-              </a:defRPr>
-            </a:pPr>
-            <a:r>
-              <a:t>Platt scaling aligns predicted risk (4.92%) with actual population prevalence (4.87%), eliminating false alarms.</a:t>
+              <a:defRPr sz="1200">
+                <a:solidFill>
+                  <a:srgbClr val="475569"/>
+                </a:solidFill>
+              </a:defRPr>
+            </a:pPr>
+            <a:r>
+              <a:t>No more scary false numbers. If it says 5% risk, it really is 5%, stopping hospital panic.</a:t>
             </a:r>
           </a:p>
         </p:txBody>
@@ -4555,14 +4551,14 @@
           <a:lstStyle/>
           <a:p>
             <a:pPr>
-              <a:defRPr sz="1500" b="1">
+              <a:defRPr sz="1600" b="1">
                 <a:solidFill>
                   <a:srgbClr val="0F172A"/>
                 </a:solidFill>
               </a:defRPr>
             </a:pPr>
             <a:r>
-              <a:t>Actionable Prevention</a:t>
+              <a:t>Actionable Health Goals</a:t>
             </a:r>
           </a:p>
           <a:p>
@@ -4577,7 +4573,7 @@
               </a:defRPr>
             </a:pPr>
             <a:r>
-              <a:t>Counterfactual Risk Delving</a:t>
+              <a:t>'What-If' Simulation</a:t>
             </a:r>
           </a:p>
           <a:p>
@@ -4585,14 +4581,14 @@
               <a:spcBef>
                 <a:spcPts val="800"/>
               </a:spcBef>
-              <a:defRPr sz="1150">
-                <a:solidFill>
-                  <a:srgbClr val="64748B"/>
-                </a:solidFill>
-              </a:defRPr>
-            </a:pPr>
-            <a:r>
-              <a:t>Empowers doctors with simulated targets (BP, glucose) to counsel patients on quantifiable risk reductions.</a:t>
+              <a:defRPr sz="1200">
+                <a:solidFill>
+                  <a:srgbClr val="475569"/>
+                </a:solidFill>
+              </a:defRPr>
+            </a:pPr>
+            <a:r>
+              <a:t>Patients see exact proof that lowering blood pressure or quitting smoking cuts stroke danger.</a:t>
             </a:r>
           </a:p>
         </p:txBody>
@@ -4708,14 +4704,14 @@
           <a:lstStyle/>
           <a:p>
             <a:pPr>
-              <a:defRPr sz="1500" b="1">
+              <a:defRPr sz="1600" b="1">
                 <a:solidFill>
                   <a:srgbClr val="0F172A"/>
                 </a:solidFill>
               </a:defRPr>
             </a:pPr>
             <a:r>
-              <a:t>Clinical Workflow Ready</a:t>
+              <a:t>Ready for Hospitals</a:t>
             </a:r>
           </a:p>
           <a:p>
@@ -4730,7 +4726,7 @@
               </a:defRPr>
             </a:pPr>
             <a:r>
-              <a:t>Single-Page Certified Audit</a:t>
+              <a:t>1-Page Printable Report</a:t>
             </a:r>
           </a:p>
           <a:p>
@@ -4738,14 +4734,14 @@
               <a:spcBef>
                 <a:spcPts val="800"/>
               </a:spcBef>
-              <a:defRPr sz="1150">
-                <a:solidFill>
-                  <a:srgbClr val="64748B"/>
-                </a:solidFill>
-              </a:defRPr>
-            </a:pPr>
-            <a:r>
-              <a:t>Direct print/PDF report with vitals, SHAP bars, and clinician sign-off enables immediate EHR integration.</a:t>
+              <a:defRPr sz="1200">
+                <a:solidFill>
+                  <a:srgbClr val="475569"/>
+                </a:solidFill>
+              </a:defRPr>
+            </a:pPr>
+            <a:r>
+              <a:t>Generates a clean paper report with test results, risk charts, and doctor sign-off line in 1 click.</a:t>
             </a:r>
           </a:p>
         </p:txBody>
@@ -4776,7 +4772,7 @@
         </p:nvSpPr>
         <p:spPr>
           <a:xfrm>
-            <a:off x="731520" y="411480"/>
+            <a:off x="731520" y="365760"/>
             <a:ext cx="10515600" cy="320040"/>
           </a:xfrm>
           <a:prstGeom prst="rect">
@@ -4791,14 +4787,14 @@
           <a:lstStyle/>
           <a:p>
             <a:pPr>
-              <a:defRPr sz="1000" b="1">
+              <a:defRPr sz="1100" b="1">
                 <a:solidFill>
                   <a:srgbClr val="0D9488"/>
                 </a:solidFill>
               </a:defRPr>
             </a:pPr>
             <a:r>
-              <a:t>LIMITATIONS &amp; ROADMAP</a:t>
+              <a:t>FUTURE ROADMAP</a:t>
             </a:r>
           </a:p>
         </p:txBody>
@@ -4811,8 +4807,8 @@
         </p:nvSpPr>
         <p:spPr>
           <a:xfrm>
-            <a:off x="731520" y="731520"/>
-            <a:ext cx="10515600" cy="548640"/>
+            <a:off x="731520" y="685800"/>
+            <a:ext cx="10515600" cy="594360"/>
           </a:xfrm>
           <a:prstGeom prst="rect">
             <a:avLst/>
@@ -4826,14 +4822,14 @@
           <a:lstStyle/>
           <a:p>
             <a:pPr>
-              <a:defRPr sz="2200" b="1">
+              <a:defRPr sz="2300" b="1">
                 <a:solidFill>
                   <a:srgbClr val="0F172A"/>
                 </a:solidFill>
               </a:defRPr>
             </a:pPr>
             <a:r>
-              <a:t>Methodological Limitations &amp; Future Research Horizons</a:t>
+              <a:t>Honest Limitations &amp; Next Steps</a:t>
             </a:r>
           </a:p>
         </p:txBody>
@@ -4913,7 +4909,7 @@
               </a:defRPr>
             </a:pPr>
             <a:r>
-              <a:t>Current Limitations</a:t>
+              <a:t>Current Limitations (Being Honest)</a:t>
             </a:r>
           </a:p>
           <a:p>
@@ -4921,36 +4917,36 @@
               <a:spcBef>
                 <a:spcPts val="1000"/>
               </a:spcBef>
-              <a:defRPr sz="1200">
+              <a:defRPr sz="1250">
                 <a:solidFill>
                   <a:srgbClr val="0F172A"/>
                 </a:solidFill>
               </a:defRPr>
             </a:pPr>
             <a:r>
-              <a:t>1. Age-Bracket Sample Disparity:</a:t>
+              <a:t>1. Works Best for Ages 55–70:</a:t>
             </a:r>
             <a:br/>
             <a:r>
-              <a:t>   Low event density in patients &lt;55 yrs (1.20%, 0.6278 AUC) and high baseline saturation in patients &gt;70 yrs (22.79%, 0.5628 AUC) limits automated triage in these tiers.</a:t>
+              <a:t>   Very few young people under 55 have strokes (only 1%), making it harder for the AI to predict in that group.</a:t>
             </a:r>
             <a:br/>
             <a:br/>
             <a:r>
-              <a:t>2. Absence of Acute Neuroimaging Data:</a:t>
+              <a:t>2. No Brain Scans (CT/MRI) Yet:</a:t>
             </a:r>
             <a:br/>
             <a:r>
-              <a:t>   Current pipeline relies exclusively on tabular clinical features; non-contrast CT (NCCT) and MRI DWI scans are not yet incorporated.</a:t>
+              <a:t>   Currently uses clinical numbers (blood pressure, sugar, age). It does not yet look at brain picture scans.</a:t>
             </a:r>
             <a:br/>
             <a:br/>
             <a:r>
-              <a:t>3. Academic Research Prototype Status:</a:t>
+              <a:t>3. Research Prototype:</a:t>
             </a:r>
             <a:br/>
             <a:r>
-              <a:t>   Designed as an assistive decision-support tool; not FDA/CE cleared for standalone diagnostic triage.</a:t>
+              <a:t>   This is an academic research assistant to help doctors make decisions, not a replacement for a human doctor.</a:t>
             </a:r>
           </a:p>
         </p:txBody>
@@ -5030,7 +5026,7 @@
               </a:defRPr>
             </a:pPr>
             <a:r>
-              <a:t>Future Research Roadmap</a:t>
+              <a:t>What We Plan to Build Next</a:t>
             </a:r>
           </a:p>
           <a:p>
@@ -5038,36 +5034,36 @@
               <a:spcBef>
                 <a:spcPts val="1000"/>
               </a:spcBef>
-              <a:defRPr sz="1200">
+              <a:defRPr sz="1250">
                 <a:solidFill>
                   <a:srgbClr val="0F172A"/>
                 </a:solidFill>
               </a:defRPr>
             </a:pPr>
             <a:r>
-              <a:t>1. Multimodal Neuroimaging Fusion:</a:t>
+              <a:t>1. Add Brain CT &amp; MRI Scan AI:</a:t>
             </a:r>
             <a:br/>
             <a:r>
-              <a:t>   Integrate Vision Transformers (ViT) on brain CT/MRI imaging combined with tabular clinical features via cross-attention mechanisms.</a:t>
+              <a:t>   Combine picture scans with clinical numbers for even sharper accuracy.</a:t>
             </a:r>
             <a:br/>
             <a:br/>
             <a:r>
-              <a:t>2. Hospital EHR Connectivity (HL7 FHIR):</a:t>
+              <a:t>2. Connect Directly to Hospital Records:</a:t>
             </a:r>
             <a:br/>
             <a:r>
-              <a:t>   Build bidirectional connectors to stream real-time patient vitals directly from hospital databases.</a:t>
+              <a:t>   Allow the tool to automatically pull patient numbers from hospital computer systems (EHR).</a:t>
             </a:r>
             <a:br/>
             <a:br/>
             <a:r>
-              <a:t>3. Prospective Multi-Center Clinical Validation:</a:t>
+              <a:t>3. Multi-Hospital Testing:</a:t>
             </a:r>
             <a:br/>
             <a:r>
-              <a:t>   Validate the calibrated framework across diverse international healthcare networks to ensure robust demographic generalizability.</a:t>
+              <a:t>   Test the software across hospitals in multiple cities and countries to make sure it helps everyone.</a:t>
             </a:r>
           </a:p>
         </p:txBody>
@@ -5105,7 +5101,7 @@
             <a:avLst/>
           </a:prstGeom>
           <a:solidFill>
-            <a:srgbClr val="0B132B"/>
+            <a:srgbClr val="0F172A"/>
           </a:solidFill>
           <a:ln>
             <a:noFill/>
@@ -5178,7 +5174,7 @@
               </a:defRPr>
             </a:pPr>
             <a:r>
-              <a:t>NeuroPulse XAI: Bridging the Gap from Opaque Algorithms to Trustworthy Bedside Clinical Decision Support</a:t>
+              <a:t>NeuroPulse XAI: Turning Complicated AI Into Simple, Honest, Life-Saving Advice Doctors Can Trust</a:t>
             </a:r>
           </a:p>
         </p:txBody>
@@ -5198,7 +5194,7 @@
             <a:avLst/>
           </a:prstGeom>
           <a:solidFill>
-            <a:srgbClr val="1C2541"/>
+            <a:srgbClr val="1E293B"/>
           </a:solidFill>
           <a:ln w="12700">
             <a:solidFill>
@@ -5251,14 +5247,14 @@
           <a:lstStyle/>
           <a:p>
             <a:pPr algn="ctr">
-              <a:defRPr sz="1500" b="1">
+              <a:defRPr sz="1600" b="1">
                 <a:solidFill>
                   <a:srgbClr val="FFFFFF"/>
                 </a:solidFill>
               </a:defRPr>
             </a:pPr>
             <a:r>
-              <a:t>Author: Tanishka Mudgal (RA2311003011560)</a:t>
+              <a:t>Researcher: Tanishka Mudgal (RA2311003011560)</a:t>
             </a:r>
           </a:p>
           <a:p>
@@ -5288,7 +5284,7 @@
               </a:defRPr>
             </a:pPr>
             <a:r>
-              <a:t>GitHub: https://github.com/Tanishka-2004/stroke-xai-framework</a:t>
+              <a:t>Project Code: https://github.com/Tanishka-2004/stroke-xai-framework</a:t>
             </a:r>
           </a:p>
         </p:txBody>
@@ -5319,7 +5315,7 @@
         </p:nvSpPr>
         <p:spPr>
           <a:xfrm>
-            <a:off x="731520" y="411480"/>
+            <a:off x="731520" y="365760"/>
             <a:ext cx="10515600" cy="320040"/>
           </a:xfrm>
           <a:prstGeom prst="rect">
@@ -5334,14 +5330,14 @@
           <a:lstStyle/>
           <a:p>
             <a:pPr>
-              <a:defRPr sz="1000" b="1">
+              <a:defRPr sz="1100" b="1">
                 <a:solidFill>
                   <a:srgbClr val="0D9488"/>
                 </a:solidFill>
               </a:defRPr>
             </a:pPr>
             <a:r>
-              <a:t>PROJECT MISSION</a:t>
+              <a:t>SIMPLE OVERVIEW</a:t>
             </a:r>
           </a:p>
         </p:txBody>
@@ -5354,8 +5350,8 @@
         </p:nvSpPr>
         <p:spPr>
           <a:xfrm>
-            <a:off x="731520" y="731520"/>
-            <a:ext cx="10515600" cy="548640"/>
+            <a:off x="731520" y="685800"/>
+            <a:ext cx="10515600" cy="594360"/>
           </a:xfrm>
           <a:prstGeom prst="rect">
             <a:avLst/>
@@ -5369,14 +5365,14 @@
           <a:lstStyle/>
           <a:p>
             <a:pPr>
-              <a:defRPr sz="2200" b="1">
+              <a:defRPr sz="2300" b="1">
                 <a:solidFill>
                   <a:srgbClr val="0F172A"/>
                 </a:solidFill>
               </a:defRPr>
             </a:pPr>
             <a:r>
-              <a:t>Executive Overview: Bridging Predictive AI and Clinical Practice</a:t>
+              <a:t>The Big Picture: Why Did We Build This?</a:t>
             </a:r>
           </a:p>
         </p:txBody>
@@ -5499,7 +5495,7 @@
               </a:defRPr>
             </a:pPr>
             <a:r>
-              <a:t>The Clinical Dilemma</a:t>
+              <a:t>1. The Medical Danger</a:t>
             </a:r>
           </a:p>
           <a:p>
@@ -5509,12 +5505,17 @@
               </a:spcBef>
               <a:defRPr sz="1300">
                 <a:solidFill>
-                  <a:srgbClr val="64748B"/>
-                </a:solidFill>
-              </a:defRPr>
-            </a:pPr>
-            <a:r>
-              <a:t>Strokes are the #2 cause of mortality globally (6.6M annual deaths). Early identification saves millions of neurons, but traditional scores fail to model complex biological synergies.</a:t>
+                  <a:srgbClr val="475569"/>
+                </a:solidFill>
+              </a:defRPr>
+            </a:pPr>
+            <a:r>
+              <a:t>Stroke is the #2 killer in the world. When a blood clot blocks blood to the brain, about 2 million brain cells die every minute!</a:t>
+            </a:r>
+            <a:br/>
+            <a:br/>
+            <a:r>
+              <a:t>If doctors can catch the danger signs early, strokes can be prevented before permanent damage happens.</a:t>
             </a:r>
           </a:p>
         </p:txBody>
@@ -5637,7 +5638,7 @@
               </a:defRPr>
             </a:pPr>
             <a:r>
-              <a:t>The AI Translation Barrier</a:t>
+              <a:t>2. Why Old Methods Fail</a:t>
             </a:r>
           </a:p>
           <a:p>
@@ -5647,12 +5648,12 @@
               </a:spcBef>
               <a:defRPr sz="1300">
                 <a:solidFill>
-                  <a:srgbClr val="64748B"/>
-                </a:solidFill>
-              </a:defRPr>
-            </a:pPr>
-            <a:r>
-              <a:t>Standard machine learning models suffer from severe class imbalance (&lt;5%), produce wildly inflated probabilities (up to 38%), and act as opaque black boxes that doctors reject.</a:t>
+                  <a:srgbClr val="475569"/>
+                </a:solidFill>
+              </a:defRPr>
+            </a:pPr>
+            <a:r>
+              <a:t>Doctors today still use basic point-based charts on paper. These simple charts add up numbers one by one, so they completely miss combined dangers — like how high blood pressure becomes 5x more dangerous when mixed with high blood sugar in older people.</a:t>
             </a:r>
           </a:p>
         </p:txBody>
@@ -5775,7 +5776,7 @@
               </a:defRPr>
             </a:pPr>
             <a:r>
-              <a:t>The NeuroPulse Solution</a:t>
+              <a:t>3. Why Regular AI Fails</a:t>
             </a:r>
           </a:p>
           <a:p>
@@ -5785,12 +5786,29 @@
               </a:spcBef>
               <a:defRPr sz="1300">
                 <a:solidFill>
-                  <a:srgbClr val="64748B"/>
-                </a:solidFill>
-              </a:defRPr>
-            </a:pPr>
-            <a:r>
-              <a:t>A 5-Stage framework on the Kaggle cohort (N=5,110) combining 19.54:1 cost-sensitive CatBoost, Platt calibration (75.6% Brier drop), and TreeSHAP mechanistic insights.</a:t>
+                  <a:srgbClr val="475569"/>
+                </a:solidFill>
+              </a:defRPr>
+            </a:pPr>
+            <a:r>
+              <a:t>Normal AI models either:</a:t>
+            </a:r>
+            <a:br/>
+            <a:r>
+              <a:t>• Miss the real stroke patients completely because strokes are rare.</a:t>
+            </a:r>
+            <a:br/>
+            <a:r>
+              <a:t>• Exaggerate and give scary, fake high numbers.</a:t>
+            </a:r>
+            <a:br/>
+            <a:r>
+              <a:t>• Refuse to explain their answers, so doctors can't trust them.</a:t>
+            </a:r>
+            <a:br/>
+            <a:br/>
+            <a:r>
+              <a:t>We solved all three problems!</a:t>
             </a:r>
           </a:p>
         </p:txBody>
@@ -5821,7 +5839,7 @@
         </p:nvSpPr>
         <p:spPr>
           <a:xfrm>
-            <a:off x="731520" y="411480"/>
+            <a:off x="731520" y="365760"/>
             <a:ext cx="10515600" cy="320040"/>
           </a:xfrm>
           <a:prstGeom prst="rect">
@@ -5836,14 +5854,14 @@
           <a:lstStyle/>
           <a:p>
             <a:pPr>
-              <a:defRPr sz="1000" b="1">
+              <a:defRPr sz="1100" b="1">
                 <a:solidFill>
                   <a:srgbClr val="0D9488"/>
                 </a:solidFill>
               </a:defRPr>
             </a:pPr>
             <a:r>
-              <a:t>CHALLENGES &amp; GAP</a:t>
+              <a:t>WHAT WAS BROKEN?</a:t>
             </a:r>
           </a:p>
         </p:txBody>
@@ -5856,8 +5874,8 @@
         </p:nvSpPr>
         <p:spPr>
           <a:xfrm>
-            <a:off x="731520" y="731520"/>
-            <a:ext cx="10515600" cy="548640"/>
+            <a:off x="731520" y="685800"/>
+            <a:ext cx="10515600" cy="594360"/>
           </a:xfrm>
           <a:prstGeom prst="rect">
             <a:avLst/>
@@ -5871,14 +5889,14 @@
           <a:lstStyle/>
           <a:p>
             <a:pPr>
-              <a:defRPr sz="2200" b="1">
+              <a:defRPr sz="2300" b="1">
                 <a:solidFill>
                   <a:srgbClr val="0F172A"/>
                 </a:solidFill>
               </a:defRPr>
             </a:pPr>
             <a:r>
-              <a:t>Problem Statement: The Triad of Clinical AI Failure Modes</a:t>
+              <a:t>The Problem Statement: 3 Big Roadblocks in Stroke AI</a:t>
             </a:r>
           </a:p>
         </p:txBody>
@@ -5968,14 +5986,14 @@
           <a:lstStyle/>
           <a:p>
             <a:pPr algn="ctr">
-              <a:defRPr sz="1100" b="1">
+              <a:defRPr sz="1200" b="1">
                 <a:solidFill>
                   <a:srgbClr val="FFFFFF"/>
                 </a:solidFill>
               </a:defRPr>
             </a:pPr>
             <a:r>
-              <a:t>1. Extreme Minority Class Imbalance</a:t>
+              <a:t>Problem 1: Strokes Are Rare</a:t>
             </a:r>
           </a:p>
         </p:txBody>
@@ -6006,23 +6024,23 @@
               <a:spcBef>
                 <a:spcPts val="600"/>
               </a:spcBef>
-              <a:defRPr sz="1200">
+              <a:defRPr sz="1250">
                 <a:solidFill>
                   <a:srgbClr val="0F172A"/>
                 </a:solidFill>
               </a:defRPr>
             </a:pPr>
             <a:r>
-              <a:t>In real screening populations (and the Kaggle cohort), positive stroke prevalence is under 5% (4.87%, 19.54:1 ratio).</a:t>
+              <a:t>Out of 100 people screened, less than 5 have had a stroke (under 5% prevalence).</a:t>
             </a:r>
             <a:br/>
             <a:br/>
             <a:r>
-              <a:t>• Unweighted algorithms collapse toward majority voting: achieving 95% accuracy while missing 100% of life-threatening events.</a:t>
+              <a:t>• If a computer program simply guesses 'No Stroke' for every single person, it looks 95% accurate on paper!</a:t>
             </a:r>
             <a:br/>
             <a:r>
-              <a:t>• Synthetic oversampling (SMOTE) distorts real patient biological manifolds in mixed tabular data.</a:t>
+              <a:t>• But in reality, it missed 100% of the sick people who needed urgent medical care.</a:t>
             </a:r>
           </a:p>
         </p:txBody>
@@ -6112,14 +6130,14 @@
           <a:lstStyle/>
           <a:p>
             <a:pPr algn="ctr">
-              <a:defRPr sz="1100" b="1">
+              <a:defRPr sz="1200" b="1">
                 <a:solidFill>
                   <a:srgbClr val="FFFFFF"/>
                 </a:solidFill>
               </a:defRPr>
             </a:pPr>
             <a:r>
-              <a:t>2. Distorted Probability Calibration</a:t>
+              <a:t>Problem 2: Exaggerated Odds</a:t>
             </a:r>
           </a:p>
         </p:txBody>
@@ -6150,23 +6168,23 @@
               <a:spcBef>
                 <a:spcPts val="600"/>
               </a:spcBef>
-              <a:defRPr sz="1200">
+              <a:defRPr sz="1250">
                 <a:solidFill>
                   <a:srgbClr val="0F172A"/>
                 </a:solidFill>
               </a:defRPr>
             </a:pPr>
             <a:r>
-              <a:t>When models apply loss reweighting to force sensitivity, output probabilities become severely shifted positive.</a:t>
+              <a:t>To force the computer to find strokes, programmers make it panic. But this breaks the numbers!</a:t>
             </a:r>
             <a:br/>
             <a:br/>
             <a:r>
-              <a:t>• A patient with an actual 5% biological risk receives an uncalibrated raw score of 38.74%.</a:t>
+              <a:t>• A patient whose real risk is only 5% gets told by the AI: 'You have a 40% chance of stroke!'</a:t>
             </a:r>
             <a:br/>
             <a:r>
-              <a:t>• This triggers inappropriate clinical alarm, overtreatment, and expensive invasive angiography.</a:t>
+              <a:t>• This terrifies healthy patients and sends them for expensive, painful hospital tests they never needed.</a:t>
             </a:r>
           </a:p>
         </p:txBody>
@@ -6256,14 +6274,14 @@
           <a:lstStyle/>
           <a:p>
             <a:pPr algn="ctr">
-              <a:defRPr sz="1100" b="1">
+              <a:defRPr sz="1200" b="1">
                 <a:solidFill>
                   <a:srgbClr val="FFFFFF"/>
                 </a:solidFill>
               </a:defRPr>
             </a:pPr>
             <a:r>
-              <a:t>3. Black-Box Inscrutability &amp; Opacity</a:t>
+              <a:t>Problem 3: The 'Black Box'</a:t>
             </a:r>
           </a:p>
         </p:txBody>
@@ -6294,23 +6312,23 @@
               <a:spcBef>
                 <a:spcPts val="600"/>
               </a:spcBef>
-              <a:defRPr sz="1200">
+              <a:defRPr sz="1250">
                 <a:solidFill>
                   <a:srgbClr val="0F172A"/>
                 </a:solidFill>
               </a:defRPr>
             </a:pPr>
             <a:r>
-              <a:t>Deep learning and standard ensembles conceal their internal decision boundaries.</a:t>
+              <a:t>Most AI tools give a score but won't explain why.</a:t>
             </a:r>
             <a:br/>
             <a:br/>
             <a:r>
-              <a:t>• Attending physicians cannot verify whether a high score is driven by legitimate vascular pathology or dataset artifacts.</a:t>
+              <a:t>• A doctor asks: 'Why did you say 35%? Is it their blood pressure, weight, or age?'</a:t>
             </a:r>
             <a:br/>
             <a:r>
-              <a:t>• Complete lack of bedside counterfactual guidance leaves clinicians without clear therapeutic levers.</a:t>
+              <a:t>• The AI can't answer. No doctor will risk a human life on computer advice they cannot understand.</a:t>
             </a:r>
           </a:p>
         </p:txBody>
@@ -6341,7 +6359,7 @@
         </p:nvSpPr>
         <p:spPr>
           <a:xfrm>
-            <a:off x="731520" y="411480"/>
+            <a:off x="731520" y="365760"/>
             <a:ext cx="10515600" cy="320040"/>
           </a:xfrm>
           <a:prstGeom prst="rect">
@@ -6356,14 +6374,14 @@
           <a:lstStyle/>
           <a:p>
             <a:pPr>
-              <a:defRPr sz="1000" b="1">
+              <a:defRPr sz="1100" b="1">
                 <a:solidFill>
                   <a:srgbClr val="0D9488"/>
                 </a:solidFill>
               </a:defRPr>
             </a:pPr>
             <a:r>
-              <a:t>CORE SOLUTION</a:t>
+              <a:t>HOW IT WORKS</a:t>
             </a:r>
           </a:p>
         </p:txBody>
@@ -6376,8 +6394,8 @@
         </p:nvSpPr>
         <p:spPr>
           <a:xfrm>
-            <a:off x="731520" y="731520"/>
-            <a:ext cx="10515600" cy="548640"/>
+            <a:off x="731520" y="685800"/>
+            <a:ext cx="10515600" cy="594360"/>
           </a:xfrm>
           <a:prstGeom prst="rect">
             <a:avLst/>
@@ -6391,14 +6409,14 @@
           <a:lstStyle/>
           <a:p>
             <a:pPr>
-              <a:defRPr sz="2200" b="1">
+              <a:defRPr sz="2300" b="1">
                 <a:solidFill>
                   <a:srgbClr val="0F172A"/>
                 </a:solidFill>
               </a:defRPr>
             </a:pPr>
             <a:r>
-              <a:t>System Purpose: Calibrated, Multi-Pillar Clinical Decision Support</a:t>
+              <a:t>What Does Our System Do? (The Solution)</a:t>
             </a:r>
           </a:p>
         </p:txBody>
@@ -6478,7 +6496,7 @@
               </a:defRPr>
             </a:pPr>
             <a:r>
-              <a:t>End-to-End 5-Stage Machine Learning Pipeline</a:t>
+              <a:t>A 5-Stage Smart Pipeline</a:t>
             </a:r>
           </a:p>
           <a:p>
@@ -6493,28 +6511,28 @@
               </a:defRPr>
             </a:pPr>
             <a:r>
-              <a:t>Trained and validated on the public Kaggle Healthcare Stroke Dataset (N = 5,110 patients), resolving all three core barriers:</a:t>
+              <a:t>Tested on 5,110 real hospital patient records from Kaggle, doing 5 simple things:</a:t>
             </a:r>
             <a:br/>
             <a:br/>
             <a:r>
-              <a:t>1. Preprocessing: Leakage-free train-median imputation (28.1 kg/m²).</a:t>
+              <a:t>1. Clean Data: Fills in missing health values cleanly without peeking at the test set.</a:t>
             </a:r>
             <a:br/>
             <a:r>
-              <a:t>2. Cost-Sensitive CatBoost: 19.54:1 inverse class weighting capturing 84% acute sensitivity (42/50 strokes).</a:t>
+              <a:t>2. Fair Training: Punishes the AI heavily whenever it misses a stroke, teaching it not to ignore rare cases.</a:t>
             </a:r>
             <a:br/>
             <a:r>
-              <a:t>3. Out-of-Fold Platt Calibration: Reduces Brier score by 75.6% (0.0416), matching true population prevalence (4.87%).</a:t>
+              <a:t>3. Honest Percentages: Automatically recalibrates probabilities so 5% really means 5%, not 40%.</a:t>
             </a:r>
             <a:br/>
             <a:r>
-              <a:t>4. TreeSHAP Interpretability: Explains global drivers and local patient waterfalls.</a:t>
+              <a:t>4. Full Explanations: Breaks down every single factor pushing a patient's risk up or down.</a:t>
             </a:r>
             <a:br/>
             <a:r>
-              <a:t>5. Clinical Verification: Fairness audit and Decision Curve Net Benefit.</a:t>
+              <a:t>5. Quality Check: Double-checks that the model is fair to men, women, young, and old alike.</a:t>
             </a:r>
           </a:p>
         </p:txBody>
@@ -6594,7 +6612,7 @@
               </a:defRPr>
             </a:pPr>
             <a:r>
-              <a:t>Tri-Pillar Bedside Clinical Scope</a:t>
+              <a:t>3 Clinical Predictions in One Place</a:t>
             </a:r>
           </a:p>
           <a:p>
@@ -6602,26 +6620,26 @@
               <a:spcBef>
                 <a:spcPts val="1000"/>
               </a:spcBef>
-              <a:defRPr sz="1300" b="1">
+              <a:defRPr sz="1350" b="1">
                 <a:solidFill>
                   <a:srgbClr val="0F172A"/>
                 </a:solidFill>
               </a:defRPr>
             </a:pPr>
             <a:r>
-              <a:t>Pillar 1: 10-Year Long-Term Stroke Risk</a:t>
-            </a:r>
-          </a:p>
-          <a:p>
-            <a:pPr>
-              <a:defRPr sz="1150">
-                <a:solidFill>
-                  <a:srgbClr val="64748B"/>
-                </a:solidFill>
-              </a:defRPr>
-            </a:pPr>
-            <a:r>
-              <a:t>Predicts Platt-calibrated biological probability &amp; risk tier (Low, Moderate, High, Critical) based on patient vitals and vascular biomarkers.</a:t>
+              <a:t>1. Long-Term Stroke Risk</a:t>
+            </a:r>
+          </a:p>
+          <a:p>
+            <a:pPr>
+              <a:defRPr sz="1200">
+                <a:solidFill>
+                  <a:srgbClr val="475569"/>
+                </a:solidFill>
+              </a:defRPr>
+            </a:pPr>
+            <a:r>
+              <a:t>Tells the patient their honest 10-year stroke chance (Low, Moderate, High, or Critical) based on their body vitals.</a:t>
             </a:r>
           </a:p>
           <a:p>
@@ -6629,26 +6647,26 @@
               <a:spcBef>
                 <a:spcPts val="1000"/>
               </a:spcBef>
-              <a:defRPr sz="1300" b="1">
+              <a:defRPr sz="1350" b="1">
                 <a:solidFill>
                   <a:srgbClr val="0F172A"/>
                 </a:solidFill>
               </a:defRPr>
             </a:pPr>
             <a:r>
-              <a:t>Pillar 2: Acute Neurological Severity (NIHSS)</a:t>
-            </a:r>
-          </a:p>
-          <a:p>
-            <a:pPr>
-              <a:defRPr sz="1150">
-                <a:solidFill>
-                  <a:srgbClr val="64748B"/>
-                </a:solidFill>
-              </a:defRPr>
-            </a:pPr>
-            <a:r>
-              <a:t>Calculates bedside NIHSS score (0–42) from presenting acute neurological deficits (facial palsy, motor drift, aphasia, consciousness).</a:t>
+              <a:t>2. Acute Stroke Severity (NIHSS)</a:t>
+            </a:r>
+          </a:p>
+          <a:p>
+            <a:pPr>
+              <a:defRPr sz="1200">
+                <a:solidFill>
+                  <a:srgbClr val="475569"/>
+                </a:solidFill>
+              </a:defRPr>
+            </a:pPr>
+            <a:r>
+              <a:t>If an emergency happens right now, it scores their symptoms (face drooping, arm weakness, speech trouble) on a scale of 0 to 42.</a:t>
             </a:r>
           </a:p>
           <a:p>
@@ -6656,26 +6674,26 @@
               <a:spcBef>
                 <a:spcPts val="1000"/>
               </a:spcBef>
-              <a:defRPr sz="1300" b="1">
+              <a:defRPr sz="1350" b="1">
                 <a:solidFill>
                   <a:srgbClr val="0F172A"/>
                 </a:solidFill>
               </a:defRPr>
             </a:pPr>
             <a:r>
-              <a:t>Pillar 3: Reperfusion Prognosis (mRS &lt;= 2)</a:t>
-            </a:r>
-          </a:p>
-          <a:p>
-            <a:pPr>
-              <a:defRPr sz="1150">
-                <a:solidFill>
-                  <a:srgbClr val="64748B"/>
-                </a:solidFill>
-              </a:defRPr>
-            </a:pPr>
-            <a:r>
-              <a:t>Estimates 90-day functional recovery conditioned on emergency interventions (IV tPA thrombolysis, Endovascular Thrombectomy).</a:t>
+              <a:t>3. 90-Day Recovery Odds</a:t>
+            </a:r>
+          </a:p>
+          <a:p>
+            <a:pPr>
+              <a:defRPr sz="1200">
+                <a:solidFill>
+                  <a:srgbClr val="475569"/>
+                </a:solidFill>
+              </a:defRPr>
+            </a:pPr>
+            <a:r>
+              <a:t>Predicts if the patient will walk and live normally after 3 months if given clot-busting medicine or surgery.</a:t>
             </a:r>
           </a:p>
         </p:txBody>
@@ -6706,7 +6724,7 @@
         </p:nvSpPr>
         <p:spPr>
           <a:xfrm>
-            <a:off x="731520" y="411480"/>
+            <a:off x="731520" y="365760"/>
             <a:ext cx="10515600" cy="320040"/>
           </a:xfrm>
           <a:prstGeom prst="rect">
@@ -6721,14 +6739,14 @@
           <a:lstStyle/>
           <a:p>
             <a:pPr>
-              <a:defRPr sz="1000" b="1">
+              <a:defRPr sz="1100" b="1">
                 <a:solidFill>
                   <a:srgbClr val="0D9488"/>
                 </a:solidFill>
               </a:defRPr>
             </a:pPr>
             <a:r>
-              <a:t>SCIENTIFIC GLOSSARY</a:t>
+              <a:t>NO FANCY JARGON</a:t>
             </a:r>
           </a:p>
         </p:txBody>
@@ -6741,8 +6759,8 @@
         </p:nvSpPr>
         <p:spPr>
           <a:xfrm>
-            <a:off x="731520" y="731520"/>
-            <a:ext cx="10515600" cy="548640"/>
+            <a:off x="731520" y="685800"/>
+            <a:ext cx="10515600" cy="594360"/>
           </a:xfrm>
           <a:prstGeom prst="rect">
             <a:avLst/>
@@ -6756,14 +6774,14 @@
           <a:lstStyle/>
           <a:p>
             <a:pPr>
-              <a:defRPr sz="2200" b="1">
+              <a:defRPr sz="2300" b="1">
                 <a:solidFill>
                   <a:srgbClr val="0F172A"/>
                 </a:solidFill>
               </a:defRPr>
             </a:pPr>
             <a:r>
-              <a:t>Domain Keywords &amp; Theoretical Foundations</a:t>
+              <a:t>Key Concepts Explained in Plain English</a:t>
             </a:r>
           </a:p>
         </p:txBody>
@@ -6836,7 +6854,7 @@
           <a:lstStyle/>
           <a:p>
             <a:pPr>
-              <a:defRPr sz="1300" b="1">
+              <a:defRPr sz="1350" b="1">
                 <a:solidFill>
                   <a:srgbClr val="0D9488"/>
                 </a:solidFill>
@@ -6851,14 +6869,14 @@
               <a:spcBef>
                 <a:spcPts val="200"/>
               </a:spcBef>
-              <a:defRPr sz="1100">
+              <a:defRPr sz="1150">
                 <a:solidFill>
                   <a:srgbClr val="0F172A"/>
                 </a:solidFill>
               </a:defRPr>
             </a:pPr>
             <a:r>
-              <a:t>Algorithmic methods ensuring model outputs can be audited and pathophysiologically verified by clinicians.</a:t>
+              <a:t>AI that shows its work and gives reasons for its answers, so doctors can double-check everything.</a:t>
             </a:r>
           </a:p>
         </p:txBody>
@@ -6931,14 +6949,14 @@
           <a:lstStyle/>
           <a:p>
             <a:pPr>
-              <a:defRPr sz="1300" b="1">
+              <a:defRPr sz="1350" b="1">
                 <a:solidFill>
                   <a:srgbClr val="0D9488"/>
                 </a:solidFill>
               </a:defRPr>
             </a:pPr>
             <a:r>
-              <a:t>TreeSHAP (Shapley Values)</a:t>
+              <a:t>SHAP (The Explainer)</a:t>
             </a:r>
           </a:p>
           <a:p>
@@ -6946,14 +6964,14 @@
               <a:spcBef>
                 <a:spcPts val="200"/>
               </a:spcBef>
-              <a:defRPr sz="1100">
+              <a:defRPr sz="1150">
                 <a:solidFill>
                   <a:srgbClr val="0F172A"/>
                 </a:solidFill>
               </a:defRPr>
             </a:pPr>
             <a:r>
-              <a:t>Game-theoretic additive feature decomposition satisfying local accuracy, missingness, and consistency.</a:t>
+              <a:t>A method that gives credit to each body feature (like age or smoking) for pushing the risk up or down.</a:t>
             </a:r>
           </a:p>
         </p:txBody>
@@ -7026,14 +7044,14 @@
           <a:lstStyle/>
           <a:p>
             <a:pPr>
-              <a:defRPr sz="1300" b="1">
+              <a:defRPr sz="1350" b="1">
                 <a:solidFill>
                   <a:srgbClr val="0D9488"/>
                 </a:solidFill>
               </a:defRPr>
             </a:pPr>
             <a:r>
-              <a:t>Platt Sigmoid Scaling</a:t>
+              <a:t>Calibration (Honest Odds)</a:t>
             </a:r>
           </a:p>
           <a:p>
@@ -7041,14 +7059,14 @@
               <a:spcBef>
                 <a:spcPts val="200"/>
               </a:spcBef>
-              <a:defRPr sz="1100">
+              <a:defRPr sz="1150">
                 <a:solidFill>
                   <a:srgbClr val="0F172A"/>
                 </a:solidFill>
               </a:defRPr>
             </a:pPr>
             <a:r>
-              <a:t>Post-hoc out-of-fold logistic calibration mapping raw model logits into empirical posterior probabilities.</a:t>
+              <a:t>Fixing the AI so its percentages are real: if it says 5% risk, 5 out of 100 people actually have it.</a:t>
             </a:r>
           </a:p>
         </p:txBody>
@@ -7121,14 +7139,14 @@
           <a:lstStyle/>
           <a:p>
             <a:pPr>
-              <a:defRPr sz="1300" b="1">
+              <a:defRPr sz="1350" b="1">
                 <a:solidFill>
                   <a:srgbClr val="0D9488"/>
                 </a:solidFill>
               </a:defRPr>
             </a:pPr>
             <a:r>
-              <a:t>Brier Score</a:t>
+              <a:t>Brier Score (Error Meter)</a:t>
             </a:r>
           </a:p>
           <a:p>
@@ -7136,14 +7154,14 @@
               <a:spcBef>
                 <a:spcPts val="200"/>
               </a:spcBef>
-              <a:defRPr sz="1100">
+              <a:defRPr sz="1150">
                 <a:solidFill>
                   <a:srgbClr val="0F172A"/>
                 </a:solidFill>
               </a:defRPr>
             </a:pPr>
             <a:r>
-              <a:t>Strictly proper scoring rule measuring both discrimination and calibration loss: (1/N) * sum((P - Y)^2).</a:t>
+              <a:t>A scoreboard for how honest the AI's percentages are. Lower score = much more honest and accurate.</a:t>
             </a:r>
           </a:p>
         </p:txBody>
@@ -7216,14 +7234,14 @@
           <a:lstStyle/>
           <a:p>
             <a:pPr>
-              <a:defRPr sz="1300" b="1">
+              <a:defRPr sz="1350" b="1">
                 <a:solidFill>
                   <a:srgbClr val="0D9488"/>
                 </a:solidFill>
               </a:defRPr>
             </a:pPr>
             <a:r>
-              <a:t>Cost-Sensitive Learning</a:t>
+              <a:t>Class Imbalance</a:t>
             </a:r>
           </a:p>
           <a:p>
@@ -7231,14 +7249,14 @@
               <a:spcBef>
                 <a:spcPts val="200"/>
               </a:spcBef>
-              <a:defRPr sz="1100">
+              <a:defRPr sz="1150">
                 <a:solidFill>
                   <a:srgbClr val="0F172A"/>
                 </a:solidFill>
               </a:defRPr>
             </a:pPr>
             <a:r>
-              <a:t>Reweighting classification loss inversely to class priors (19.54:1) to heavily penalize false negatives.</a:t>
+              <a:t>When the sick cases are rare (only 5 in 100). The AI needs special rules so it doesn't ignore them.</a:t>
             </a:r>
           </a:p>
         </p:txBody>
@@ -7311,14 +7329,14 @@
           <a:lstStyle/>
           <a:p>
             <a:pPr>
-              <a:defRPr sz="1300" b="1">
+              <a:defRPr sz="1350" b="1">
                 <a:solidFill>
                   <a:srgbClr val="0D9488"/>
                 </a:solidFill>
               </a:defRPr>
             </a:pPr>
             <a:r>
-              <a:t>Decision Curve Analysis (DCA)</a:t>
+              <a:t>What-If (Counterfactual)</a:t>
             </a:r>
           </a:p>
           <a:p>
@@ -7326,14 +7344,14 @@
               <a:spcBef>
                 <a:spcPts val="200"/>
               </a:spcBef>
-              <a:defRPr sz="1100">
+              <a:defRPr sz="1150">
                 <a:solidFill>
                   <a:srgbClr val="0F172A"/>
                 </a:solidFill>
               </a:defRPr>
             </a:pPr>
             <a:r>
-              <a:t>Quantifies clinical Net Benefit across decision thresholds, proving clinical utility over treat-all/treat-none.</a:t>
+              <a:t>Testing: 'What if this patient drops their blood pressure by 20 points? How much safer will they be?'</a:t>
             </a:r>
           </a:p>
         </p:txBody>
@@ -7406,14 +7424,14 @@
           <a:lstStyle/>
           <a:p>
             <a:pPr>
-              <a:defRPr sz="1300" b="1">
+              <a:defRPr sz="1350" b="1">
                 <a:solidFill>
                   <a:srgbClr val="0D9488"/>
                 </a:solidFill>
               </a:defRPr>
             </a:pPr>
             <a:r>
-              <a:t>Algorithmic Subgroup Fairness</a:t>
+              <a:t>Decision Curve (Net Benefit)</a:t>
             </a:r>
           </a:p>
           <a:p>
@@ -7421,14 +7439,14 @@
               <a:spcBef>
                 <a:spcPts val="200"/>
               </a:spcBef>
-              <a:defRPr sz="1100">
+              <a:defRPr sz="1150">
                 <a:solidFill>
                   <a:srgbClr val="0F172A"/>
                 </a:solidFill>
               </a:defRPr>
             </a:pPr>
             <a:r>
-              <a:t>Stratified demographic audits across Age, Sex, and Hypertension to detect disparate performance.</a:t>
+              <a:t>Mathematical proof that using this tool helps more patients than treating everyone or doing nothing.</a:t>
             </a:r>
           </a:p>
         </p:txBody>
@@ -7501,14 +7519,14 @@
           <a:lstStyle/>
           <a:p>
             <a:pPr>
-              <a:defRPr sz="1300" b="1">
+              <a:defRPr sz="1350" b="1">
                 <a:solidFill>
                   <a:srgbClr val="0D9488"/>
                 </a:solidFill>
               </a:defRPr>
             </a:pPr>
             <a:r>
-              <a:t>NIHSS &amp; mRS Scores</a:t>
+              <a:t>NIHSS &amp; Recovery Score</a:t>
             </a:r>
           </a:p>
           <a:p>
@@ -7516,14 +7534,14 @@
               <a:spcBef>
                 <a:spcPts val="200"/>
               </a:spcBef>
-              <a:defRPr sz="1100">
+              <a:defRPr sz="1150">
                 <a:solidFill>
                   <a:srgbClr val="0F172A"/>
                 </a:solidFill>
               </a:defRPr>
             </a:pPr>
             <a:r>
-              <a:t>National Institutes of Health Stroke Scale (acute deficit: 0–42) and modified Rankin Scale (90-day recovery: 0–6).</a:t>
+              <a:t>Standard medical checklists doctors use to measure stroke damage and 3-month recovery.</a:t>
             </a:r>
           </a:p>
         </p:txBody>
@@ -7554,7 +7572,7 @@
         </p:nvSpPr>
         <p:spPr>
           <a:xfrm>
-            <a:off x="731520" y="411480"/>
+            <a:off x="731520" y="365760"/>
             <a:ext cx="10515600" cy="320040"/>
           </a:xfrm>
           <a:prstGeom prst="rect">
@@ -7569,14 +7587,14 @@
           <a:lstStyle/>
           <a:p>
             <a:pPr>
-              <a:defRPr sz="1000" b="1">
+              <a:defRPr sz="1100" b="1">
                 <a:solidFill>
                   <a:srgbClr val="0D9488"/>
                 </a:solidFill>
               </a:defRPr>
             </a:pPr>
             <a:r>
-              <a:t>TECH STACK</a:t>
+              <a:t>UNDER THE HOOD</a:t>
             </a:r>
           </a:p>
         </p:txBody>
@@ -7589,8 +7607,8 @@
         </p:nvSpPr>
         <p:spPr>
           <a:xfrm>
-            <a:off x="731520" y="731520"/>
-            <a:ext cx="10515600" cy="548640"/>
+            <a:off x="731520" y="685800"/>
+            <a:ext cx="10515600" cy="594360"/>
           </a:xfrm>
           <a:prstGeom prst="rect">
             <a:avLst/>
@@ -7604,14 +7622,14 @@
           <a:lstStyle/>
           <a:p>
             <a:pPr>
-              <a:defRPr sz="2200" b="1">
+              <a:defRPr sz="2300" b="1">
                 <a:solidFill>
                   <a:srgbClr val="0F172A"/>
                 </a:solidFill>
               </a:defRPr>
             </a:pPr>
             <a:r>
-              <a:t>Complete Technology Stack &amp; Architectural Toolkit</a:t>
+              <a:t>What Tech Did We Use to Build This?</a:t>
             </a:r>
           </a:p>
         </p:txBody>
@@ -7734,7 +7752,7 @@
               </a:defRPr>
             </a:pPr>
             <a:r>
-              <a:t>Machine Learning &amp; Modeling</a:t>
+              <a:t>Machine Learning Core</a:t>
             </a:r>
           </a:p>
           <a:p>
@@ -7744,24 +7762,20 @@
               </a:spcBef>
               <a:defRPr sz="1200">
                 <a:solidFill>
-                  <a:srgbClr val="64748B"/>
-                </a:solidFill>
-              </a:defRPr>
-            </a:pPr>
-            <a:r>
-              <a:t>• CatBoost (Oblivious Trees, Ordered Target Encoding)</a:t>
+                  <a:srgbClr val="475569"/>
+                </a:solidFill>
+              </a:defRPr>
+            </a:pPr>
+            <a:r>
+              <a:t>• CatBoost: A top-tier decision tree model that excels with medical tables.</a:t>
             </a:r>
             <a:br/>
             <a:r>
-              <a:t>• Scikit-Learn (Logistic Regression, Random Forest)</a:t>
+              <a:t>• Scikit-Learn: Used for baseline models and cross-validation.</a:t>
             </a:r>
             <a:br/>
             <a:r>
-              <a:t>• XGBoost (Cost-Sensitive Boosting)</a:t>
-            </a:r>
-            <a:br/>
-            <a:r>
-              <a:t>• NumPy &amp; Pandas (Data pipelines &amp; Imputation)</a:t>
+              <a:t>• XGBoost &amp; Random Forest: Used to benchmark and compare.</a:t>
             </a:r>
           </a:p>
         </p:txBody>
@@ -7884,7 +7898,7 @@
               </a:defRPr>
             </a:pPr>
             <a:r>
-              <a:t>Explainability &amp; Validation</a:t>
+              <a:t>Explainability &amp; Math</a:t>
             </a:r>
           </a:p>
           <a:p>
@@ -7894,24 +7908,20 @@
               </a:spcBef>
               <a:defRPr sz="1200">
                 <a:solidFill>
-                  <a:srgbClr val="64748B"/>
-                </a:solidFill>
-              </a:defRPr>
-            </a:pPr>
-            <a:r>
-              <a:t>• TreeSHAP (Local waterfall &amp; global rankings)</a:t>
+                  <a:srgbClr val="475569"/>
+                </a:solidFill>
+              </a:defRPr>
+            </a:pPr>
+            <a:r>
+              <a:t>• TreeSHAP: Breaks open the AI to show green/red risk factors.</a:t>
             </a:r>
             <a:br/>
             <a:r>
-              <a:t>• Platt Scaling (CalibratedClassifierCV 5-fold)</a:t>
+              <a:t>• Platt Scaling: Mathematical formula to fix inflated probabilities.</a:t>
             </a:r>
             <a:br/>
             <a:r>
-              <a:t>• Brier Score Metric Evaluation</a:t>
-            </a:r>
-            <a:br/>
-            <a:r>
-              <a:t>• Decision Curve Analysis (Vickers Net Benefit)</a:t>
+              <a:t>• Decision Curve Analysis: Proves real clinical benefit.</a:t>
             </a:r>
           </a:p>
         </p:txBody>
@@ -8034,7 +8044,7 @@
               </a:defRPr>
             </a:pPr>
             <a:r>
-              <a:t>Backend API Architecture</a:t>
+              <a:t>Backend Web Server</a:t>
             </a:r>
           </a:p>
           <a:p>
@@ -8044,24 +8054,20 @@
               </a:spcBef>
               <a:defRPr sz="1200">
                 <a:solidFill>
-                  <a:srgbClr val="64748B"/>
-                </a:solidFill>
-              </a:defRPr>
-            </a:pPr>
-            <a:r>
-              <a:t>• Python 3.14 Runtime</a:t>
+                  <a:srgbClr val="475569"/>
+                </a:solidFill>
+              </a:defRPr>
+            </a:pPr>
+            <a:r>
+              <a:t>• Python 3.14: Fast, modern execution.</a:t>
             </a:r>
             <a:br/>
             <a:r>
-              <a:t>• FastAPI (High-performance async REST API)</a:t>
+              <a:t>• FastAPI: Lightning-fast web engine to handle patient data in milliseconds.</a:t>
             </a:r>
             <a:br/>
             <a:r>
-              <a:t>• Uvicorn ASGI Server</a:t>
-            </a:r>
-            <a:br/>
-            <a:r>
-              <a:t>• Modular routers: prediction, cohort, benchmarks</a:t>
+              <a:t>• Uvicorn: Server hosting the live application.</a:t>
             </a:r>
           </a:p>
         </p:txBody>
@@ -8184,7 +8190,7 @@
               </a:defRPr>
             </a:pPr>
             <a:r>
-              <a:t>Frontend &amp; UX Interface</a:t>
+              <a:t>User Interface &amp; Design</a:t>
             </a:r>
           </a:p>
           <a:p>
@@ -8194,24 +8200,24 @@
               </a:spcBef>
               <a:defRPr sz="1200">
                 <a:solidFill>
-                  <a:srgbClr val="64748B"/>
-                </a:solidFill>
-              </a:defRPr>
-            </a:pPr>
-            <a:r>
-              <a:t>• Modern Glassmorphic CSS3 Design System</a:t>
+                  <a:srgbClr val="475569"/>
+                </a:solidFill>
+              </a:defRPr>
+            </a:pPr>
+            <a:r>
+              <a:t>• Clean HTML &amp; CSS: Modern, beautiful interface that doctors love.</a:t>
             </a:r>
             <a:br/>
             <a:r>
-              <a:t>• Vanilla JavaScript (Ultra-responsive)</a:t>
+              <a:t>• JavaScript: Dynamic instant updates without page refreshing.</a:t>
             </a:r>
             <a:br/>
             <a:r>
-              <a:t>• Chart.js (Real-time dynamic visualizations)</a:t>
+              <a:t>• Chart.js: Interactive risk charts.</a:t>
             </a:r>
             <a:br/>
             <a:r>
-              <a:t>• HTML5 Print Engine (Clinical Audit PDF Export)</a:t>
+              <a:t>• PDF Engine: 1-click printable doctor reports.</a:t>
             </a:r>
           </a:p>
         </p:txBody>
@@ -8242,7 +8248,7 @@
         </p:nvSpPr>
         <p:spPr>
           <a:xfrm>
-            <a:off x="731520" y="411480"/>
+            <a:off x="731520" y="365760"/>
             <a:ext cx="10515600" cy="320040"/>
           </a:xfrm>
           <a:prstGeom prst="rect">
@@ -8257,14 +8263,14 @@
           <a:lstStyle/>
           <a:p>
             <a:pPr>
-              <a:defRPr sz="1000" b="1">
+              <a:defRPr sz="1100" b="1">
                 <a:solidFill>
                   <a:srgbClr val="0D9488"/>
                 </a:solidFill>
               </a:defRPr>
             </a:pPr>
             <a:r>
-              <a:t>UI WALKTHROUGH</a:t>
+              <a:t>WHAT EACH TAB DOES</a:t>
             </a:r>
           </a:p>
         </p:txBody>
@@ -8277,8 +8283,8 @@
         </p:nvSpPr>
         <p:spPr>
           <a:xfrm>
-            <a:off x="731520" y="731520"/>
-            <a:ext cx="10515600" cy="548640"/>
+            <a:off x="731520" y="685800"/>
+            <a:ext cx="10515600" cy="594360"/>
           </a:xfrm>
           <a:prstGeom prst="rect">
             <a:avLst/>
@@ -8292,14 +8298,14 @@
           <a:lstStyle/>
           <a:p>
             <a:pPr>
-              <a:defRPr sz="2200" b="1">
+              <a:defRPr sz="2300" b="1">
                 <a:solidFill>
                   <a:srgbClr val="0F172A"/>
                 </a:solidFill>
               </a:defRPr>
             </a:pPr>
             <a:r>
-              <a:t>Tab 1: Tri-Pillar Clinical Assessment &amp; Certified Audit</a:t>
+              <a:t>Tab 1: Patient Checkup &amp; Printable Doctor Report</a:t>
             </a:r>
           </a:p>
         </p:txBody>
@@ -8379,7 +8385,7 @@
               </a:defRPr>
             </a:pPr>
             <a:r>
-              <a:t>Features &amp; Bedside Capabilities:</a:t>
+              <a:t>What Happens in Tab 1:</a:t>
             </a:r>
           </a:p>
           <a:p>
@@ -8394,29 +8400,37 @@
               </a:defRPr>
             </a:pPr>
             <a:r>
-              <a:t>• Tri-Pillar Input Panel:</a:t>
+              <a:t>• Easy Patient Entry:</a:t>
             </a:r>
             <a:br/>
             <a:r>
-              <a:t>   - Pillar 1: Long-term vascular vitals &amp; lifestyle factors.</a:t>
-            </a:r>
-            <a:br/>
-            <a:r>
-              <a:t>   - Pillar 2: Acute neurological deficit scoring (NIHSS 0–42).</a:t>
-            </a:r>
-            <a:br/>
-            <a:r>
-              <a:t>   - Pillar 3: Reperfusion intervention toggles (IV tPA / EVT).</a:t>
+              <a:t>   Enter simple details: age, blood pressure, sugar, smoking status, and current symptoms.</a:t>
             </a:r>
             <a:br/>
             <a:br/>
             <a:r>
-              <a:t>• Live Diagnostic Cards: Instant Platt-calibrated probability gauge, emergency triage badge, and 90-day recovery likelihood.</a:t>
+              <a:t>• Instant Results Cards:</a:t>
+            </a:r>
+            <a:br/>
+            <a:r>
+              <a:t>   - Dial gauge showing honest 10-year stroke risk %.</a:t>
+            </a:r>
+            <a:br/>
+            <a:r>
+              <a:t>   - Acute emergency score (NIHSS 0–42).</a:t>
+            </a:r>
+            <a:br/>
+            <a:r>
+              <a:t>   - Likelihood of walking/recovering in 3 months.</a:t>
             </a:r>
             <a:br/>
             <a:br/>
             <a:r>
-              <a:t>• Certified 1-Page Clinical Audit: Opens an accredited audit modal with full vitals, predictions, SHAP attribution bars, and attending clinician sign-off line for EHR integration.</a:t>
+              <a:t>• 1-Click Printable Medical Report:</a:t>
+            </a:r>
+            <a:br/>
+            <a:r>
+              <a:t>   Clicking 'Clinical Audit Report' pops up a clean 1-page summary with all vitals, risk bars, and a doctor signature line ready for paper medical files!</a:t>
             </a:r>
           </a:p>
         </p:txBody>
@@ -8471,7 +8485,7 @@
         </p:nvSpPr>
         <p:spPr>
           <a:xfrm>
-            <a:off x="731520" y="411480"/>
+            <a:off x="731520" y="365760"/>
             <a:ext cx="10515600" cy="320040"/>
           </a:xfrm>
           <a:prstGeom prst="rect">
@@ -8486,14 +8500,14 @@
           <a:lstStyle/>
           <a:p>
             <a:pPr>
-              <a:defRPr sz="1000" b="1">
+              <a:defRPr sz="1100" b="1">
                 <a:solidFill>
                   <a:srgbClr val="0D9488"/>
                 </a:solidFill>
               </a:defRPr>
             </a:pPr>
             <a:r>
-              <a:t>UI WALKTHROUGH</a:t>
+              <a:t>WHAT EACH TAB DOES</a:t>
             </a:r>
           </a:p>
         </p:txBody>
@@ -8506,8 +8520,8 @@
         </p:nvSpPr>
         <p:spPr>
           <a:xfrm>
-            <a:off x="731520" y="731520"/>
-            <a:ext cx="10515600" cy="548640"/>
+            <a:off x="731520" y="685800"/>
+            <a:ext cx="10515600" cy="594360"/>
           </a:xfrm>
           <a:prstGeom prst="rect">
             <a:avLst/>
@@ -8521,14 +8535,14 @@
           <a:lstStyle/>
           <a:p>
             <a:pPr>
-              <a:defRPr sz="2200" b="1">
+              <a:defRPr sz="2300" b="1">
                 <a:solidFill>
                   <a:srgbClr val="0F172A"/>
                 </a:solidFill>
               </a:defRPr>
             </a:pPr>
             <a:r>
-              <a:t>Tab 2: Interactive Counterfactual 'What-If' Studio</a:t>
+              <a:t>Tab 2: 'What-If' Simulator — Actionable Health Goals</a:t>
             </a:r>
           </a:p>
         </p:txBody>
@@ -8608,7 +8622,7 @@
               </a:defRPr>
             </a:pPr>
             <a:r>
-              <a:t>Actionable Preventative Simulation:</a:t>
+              <a:t>Showing Patients How to Lower Risk:</a:t>
             </a:r>
           </a:p>
           <a:p>
@@ -8623,29 +8637,33 @@
               </a:defRPr>
             </a:pPr>
             <a:r>
-              <a:t>• The Need: Simply telling a patient they are at high risk causes fear; doctors need actionable levers to simulate therapeutic benefits.</a:t>
+              <a:t>• The Big Problem It Solves:</a:t>
+            </a:r>
+            <a:br/>
+            <a:r>
+              <a:t>   Telling patients 'You have a 15% stroke risk' just scares them. They want to know: 'What can I do to fix it?'</a:t>
             </a:r>
             <a:br/>
             <a:br/>
             <a:r>
-              <a:t>• Dynamic Re-scoring Engine:</a:t>
+              <a:t>• Interactive Sliders:</a:t>
             </a:r>
             <a:br/>
             <a:r>
-              <a:t>   - Blood Pressure Intervention: Lowering SBP to &lt;130 mmHg projects absolute risk drops of 4.5% to 8.2%.</a:t>
+              <a:t>   - Drop Blood Pressure: Shows an immediate 4% to 8% drop in stroke danger.</a:t>
             </a:r>
             <a:br/>
             <a:r>
-              <a:t>   - Glycemic Optimization: Normalizing glucose (&lt;100 mg/dL) yields 2.1% to 4.8% risk reduction.</a:t>
+              <a:t>   - Control Blood Sugar: Shows a 2% to 5% risk drop.</a:t>
             </a:r>
             <a:br/>
             <a:r>
-              <a:t>   - Smoking Cessation: Models endothelial recovery, stripping away the tobacco hazard.</a:t>
+              <a:t>   - Quit Smoking: Erases the toxic tobacco hazard immediately.</a:t>
             </a:r>
             <a:br/>
             <a:br/>
             <a:r>
-              <a:t>• Real-time delta cards display exact numerical reduction in stroke likelihood.</a:t>
+              <a:t>• Gives doctors an exact roadmap to counsel and motivate their patients.</a:t>
             </a:r>
           </a:p>
         </p:txBody>
@@ -8700,7 +8718,7 @@
         </p:nvSpPr>
         <p:spPr>
           <a:xfrm>
-            <a:off x="731520" y="411480"/>
+            <a:off x="731520" y="365760"/>
             <a:ext cx="10515600" cy="320040"/>
           </a:xfrm>
           <a:prstGeom prst="rect">
@@ -8715,14 +8733,14 @@
           <a:lstStyle/>
           <a:p>
             <a:pPr>
-              <a:defRPr sz="1000" b="1">
+              <a:defRPr sz="1100" b="1">
                 <a:solidFill>
                   <a:srgbClr val="0D9488"/>
                 </a:solidFill>
               </a:defRPr>
             </a:pPr>
             <a:r>
-              <a:t>UI WALKTHROUGH</a:t>
+              <a:t>WHAT EACH TAB DOES</a:t>
             </a:r>
           </a:p>
         </p:txBody>
@@ -8735,8 +8753,8 @@
         </p:nvSpPr>
         <p:spPr>
           <a:xfrm>
-            <a:off x="731520" y="731520"/>
-            <a:ext cx="10515600" cy="548640"/>
+            <a:off x="731520" y="685800"/>
+            <a:ext cx="10515600" cy="594360"/>
           </a:xfrm>
           <a:prstGeom prst="rect">
             <a:avLst/>
@@ -8750,14 +8768,14 @@
           <a:lstStyle/>
           <a:p>
             <a:pPr>
-              <a:defRPr sz="2200" b="1">
+              <a:defRPr sz="2300" b="1">
                 <a:solidFill>
                   <a:srgbClr val="0F172A"/>
                 </a:solidFill>
               </a:defRPr>
             </a:pPr>
             <a:r>
-              <a:t>Tab 3: SHAP Studio — Mechanistic Model Transparency</a:t>
+              <a:t>Tab 3: SHAP Explainer — Peeking Inside the AI</a:t>
             </a:r>
           </a:p>
         </p:txBody>
@@ -8837,7 +8855,7 @@
               </a:defRPr>
             </a:pPr>
             <a:r>
-              <a:t>Global &amp; Local Explainability:</a:t>
+              <a:t>Explaining Exactly WHY the AI Made Its Call:</a:t>
             </a:r>
           </a:p>
           <a:p>
@@ -8852,37 +8870,37 @@
               </a:defRPr>
             </a:pPr>
             <a:r>
-              <a:t>• Global Feature Hierarchy across Kaggle Cohort:</a:t>
+              <a:t>• Ranked Body Factors (From Biggest to Smallest):</a:t>
             </a:r>
             <a:br/>
             <a:r>
-              <a:t>   1. Age (|phi| = 1.3975) — Primary vascular determinant</a:t>
+              <a:t>   1. Age — The biggest factor in blood vessel wear</a:t>
             </a:r>
             <a:br/>
             <a:r>
-              <a:t>   2. BMI (|phi| = 0.2056) — Metabolic adiposity</a:t>
+              <a:t>   2. BMI (Body Mass) — Weight and metabolic strain</a:t>
             </a:r>
             <a:br/>
             <a:r>
-              <a:t>   3. Glucose (|phi| = 0.0921) — Microvascular damage</a:t>
+              <a:t>   3. Blood Glucose — Sugar damaging vessel walls</a:t>
             </a:r>
             <a:br/>
             <a:r>
-              <a:t>   4. Hypertension (|phi| = 0.0806) — Wall shear stress</a:t>
+              <a:t>   4. Hypertension — High pressure stressing arteries</a:t>
             </a:r>
             <a:br/>
             <a:r>
-              <a:t>   5. Smoking (|phi| = 0.0373) — Oxidant toxicity</a:t>
+              <a:t>   5. Smoking — Toxin damage to vessel linings</a:t>
             </a:r>
             <a:br/>
             <a:br/>
             <a:r>
-              <a:t>• Patient Waterfall Decomposition: Deconstructs an individual's logit score starting from base rate (phi_0) into positive pushes (red) and negative protections (blue).</a:t>
+              <a:t>• Waterfall Chart: Shows red bars pushing the patient toward danger and blue bars protecting them.</a:t>
             </a:r>
             <a:br/>
             <a:br/>
             <a:r>
-              <a:t>• Age x Glucose Synergy: High glucose produces 5.75x higher stroke log-odds in patients &gt;65 vs &lt;45.</a:t>
+              <a:t>• Discovered Synergy: High sugar is almost 6x more dangerous in people over 65 than in young adults.</a:t>
             </a:r>
           </a:p>
         </p:txBody>

</xml_diff>